<commit_message>
Add monthly building activity features and refresh reports
</commit_message>
<xml_diff>
--- a/result/project_presentation_3slides.pptx
+++ b/result/project_presentation_3slides.pptx
@@ -3209,7 +3209,7 @@
               </a:defRPr>
             </a:pPr>
             <a:r>
-              <a:t>?????/????????????????????</a:t>
+              <a:t>????????????????????????????????</a:t>
             </a:r>
           </a:p>
           <a:p>
@@ -3224,7 +3224,7 @@
               </a:defRPr>
             </a:pPr>
             <a:r>
-              <a:t>??????????????????????</a:t>
+              <a:t>???? raw?silver?model?result ??</a:t>
             </a:r>
           </a:p>
           <a:p>
@@ -3239,7 +3239,7 @@
               </a:defRPr>
             </a:pPr>
             <a:r>
-              <a:t>???? raw?silver?model?result ??</a:t>
+              <a:t>?????? city_monthly_train_ready.csv</a:t>
             </a:r>
           </a:p>
           <a:p>
@@ -3254,7 +3254,7 @@
               </a:defRPr>
             </a:pPr>
             <a:r>
-              <a:t>raw ???????silver ???????</a:t>
+              <a:t>????? 157 ??96 ??????? 2013-01 ? 2026-01</a:t>
             </a:r>
           </a:p>
           <a:p>
@@ -3269,7 +3269,7 @@
               </a:defRPr>
             </a:pPr>
             <a:r>
-              <a:t>model ????????????result ???????</a:t>
+              <a:t>??????????? footprint?????????????</a:t>
             </a:r>
           </a:p>
           <a:p>
@@ -3284,22 +3284,7 @@
               </a:defRPr>
             </a:pPr>
             <a:r>
-              <a:t>?????? city_monthly_train_ready.csv</a:t>
-            </a:r>
-          </a:p>
-          <a:p>
-            <a:pPr>
-              <a:spcAft>
-                <a:spcPts val="800"/>
-              </a:spcAft>
-              <a:defRPr sz="1700">
-                <a:solidFill>
-                  <a:srgbClr val="1F2937"/>
-                </a:solidFill>
-              </a:defRPr>
-            </a:pPr>
-            <a:r>
-              <a:t>????? 157 ??89 ??????? 2013-01 ? 2026-01</a:t>
+              <a:t>???? target_electricity_total_t_plus_1m</a:t>
             </a:r>
           </a:p>
         </p:txBody>
@@ -3499,7 +3484,7 @@
               </a:defRPr>
             </a:pPr>
             <a:r>
-              <a:t>?????? C&amp;SD ?????????</a:t>
+              <a:t>?????? C&amp;SD ??????</a:t>
             </a:r>
           </a:p>
           <a:p>
@@ -3514,7 +3499,7 @@
               </a:defRPr>
             </a:pPr>
             <a:r>
-              <a:t>??????????????????????????????EV charger ? building footprint</a:t>
+              <a:t>???????????????????????????? Buildings Department ???????</a:t>
             </a:r>
           </a:p>
           <a:p>
@@ -3529,7 +3514,7 @@
               </a:defRPr>
             </a:pPr>
             <a:r>
-              <a:t>?????????????????</a:t>
+              <a:t>?????????????????????</a:t>
             </a:r>
           </a:p>
           <a:p>
@@ -3544,7 +3529,7 @@
               </a:defRPr>
             </a:pPr>
             <a:r>
-              <a:t>?????????????????????</a:t>
+              <a:t>????????? silver ???????????</a:t>
             </a:r>
           </a:p>
           <a:p>
@@ -3559,7 +3544,7 @@
               </a:defRPr>
             </a:pPr>
             <a:r>
-              <a:t>??? lag???????????????</a:t>
+              <a:t>????????????????occupation permits??????????????</a:t>
             </a:r>
           </a:p>
           <a:p>
@@ -3574,7 +3559,7 @@
               </a:defRPr>
             </a:pPr>
             <a:r>
-              <a:t>???? city_monthly_train_ready.csv ?????</a:t>
+              <a:t>???????????? train-ready ???</a:t>
             </a:r>
           </a:p>
         </p:txBody>
@@ -3789,7 +3774,7 @@
               </a:defRPr>
             </a:pPr>
             <a:r>
-              <a:t>Random Forest ???MAE 456.93?RMSE 609.79?R2 0.9438</a:t>
+              <a:t>Random Forest ???MAE 454.19?RMSE 614.60?R2 0.9429</a:t>
             </a:r>
           </a:p>
           <a:p>
@@ -3819,7 +3804,7 @@
               </a:defRPr>
             </a:pPr>
             <a:r>
-              <a:t>Multiple regression ??????????????????????</a:t>
+              <a:t>Multiple regression ???????????????????????????</a:t>
             </a:r>
           </a:p>
           <a:p>
@@ -3849,7 +3834,7 @@
               </a:defRPr>
             </a:pPr>
             <a:r>
-              <a:t>Multiple regression?MAE 784.25?RMSE 944.58?R2 0.8652</a:t>
+              <a:t>Multiple regression?MAE 684.98?RMSE 857.50?R2 0.8889</a:t>
             </a:r>
           </a:p>
           <a:p>
@@ -3864,7 +3849,7 @@
               </a:defRPr>
             </a:pPr>
             <a:r>
-              <a:t>??????????????????????????</a:t>
+              <a:t>?????????????????????????????</a:t>
             </a:r>
           </a:p>
         </p:txBody>

</xml_diff>